<commit_message>
Materialien neu gebaut (D15, zweiter Teil): Akten, Papier-Bosse, Probeklausur eA, Warm-up-Karten, Präsentationen W0/W1/W3/W4, Lehrerhinweise W5 samt PDFs
Gebaut mit bauen.py und expliziter Quellliste; akten, loesungen, lehrkraft neu erzeugt (--pruefen: 0 Probleme),
PDFs unveränderter Dokumente zurückgesetzt.

Co-Authored-By: Claude Opus 5.5 <noreply@anthropic.com>
Claude-Session: https://claude.ai/code/session_01JKXVQqFeKVmyQ9jfHw4db3
</commit_message>
<xml_diff>
--- a/materialien/Welt0_Antike/1_Praesentation/KR_W0_Praesentation_Antike.pptx
+++ b/materialien/Welt0_Antike/1_Praesentation/KR_W0_Praesentation_Antike.pptx
@@ -139,7 +139,7 @@
   <p:extLst>
     <p:ext uri="{521415D9-36F7-43E2-AB2F-B90AF26B5E84}">
       <p14:sectionLst xmlns:p14="http://schemas.microsoft.com/office/powerpoint/2010/main">
-        <p14:section name="DS 1 · Skytale" id="{12ddeb95-7ea5-cfe0-3799-008cc5fe3806}">
+        <p14:section name="DS 1 · Skytale" id="{73334c6b-155c-389d-5d71-1759986c3fe8}">
           <p14:sldIdLst>
             <p14:sldId id="256"/>
             <p14:sldId id="257"/>
@@ -154,7 +154,7 @@
             <p14:sldId id="266"/>
           </p14:sldIdLst>
         </p14:section>
-        <p14:section name="DS 2 · Caesar" id="{a631e2b9-9a61-d3cf-f283-368e15cae197}">
+        <p14:section name="DS 2 · Caesar" id="{09f5065a-aa17-935b-8f51-4675f0d13f3b}">
           <p14:sldIdLst>
             <p14:sldId id="267"/>
             <p14:sldId id="268"/>
@@ -170,7 +170,7 @@
             <p14:sldId id="278"/>
           </p14:sldIdLst>
         </p14:section>
-        <p14:section name="DS 3 · Werkstatt" id="{c26237a6-aa1b-3d82-f6e3-5d443831f9f6}">
+        <p14:section name="DS 3 · Werkstatt" id="{b76a3d87-c57a-cb4a-7deb-eb37b2ac6237}">
           <p14:sldIdLst>
             <p14:sldId id="279"/>
             <p14:sldId id="280"/>
@@ -179,7 +179,7 @@
             <p14:sldId id="283"/>
           </p14:sldIdLst>
         </p14:section>
-        <p14:section name="DS 3 · Fremde Chiffre" id="{5dcd05d1-e845-d328-31e5-28033fdfe56d}">
+        <p14:section name="DS 3 · Fremde Chiffre" id="{ce4b2950-1441-41a7-2ff1-e73f5ca5b796}">
           <p14:sldIdLst>
             <p14:sldId id="284"/>
             <p14:sldId id="285"/>
@@ -680,7 +680,7 @@
           <a:p>
             <a:r>
               <a:rPr lang="en-US" dirty="0"/>
-              <a:t>Folie zum Herumgehen während der Übungsphase (Akte W0·1). Beispiel = Lab-Aufgabe W0-L1-03. Beim Gartenzaun gibt es kein Füllzeichen.</a:t>
+              <a:t>Folie zum Herumgehen während der Übungsphase (Akte W0·1). Eigenes Beispiel (nicht die Lab-Aufgabe W0-L1-03, Korrektur D15). Beim Gartenzaun gibt es kein Füllzeichen.</a:t>
             </a:r>
             <a:endParaRPr lang="en-US" dirty="0"/>
           </a:p>
@@ -2542,8 +2542,9 @@
           <a:p>
             <a:r>
               <a:rPr lang="en-US" dirty="0"/>
-              <a:t>F3 · 2 min. Spalte 1 von oben nach unten = D, T, T, M – die ersten vier Geheimtextbuchstaben.
-Begriffe am Fund benennen: Klartext (die flotte …), Geheimtext (DTTMI …), Schlüssel = Umfang des Stabes = 4 Zeilen.
+              <a:t>F3 · 2 min. Spalte 1 von oben nach unten = D, T, T, M – die ersten vier Geheimtextbuchstaben; die übrigen Spalten füllen die Teams an der Tafel (die Folie zeigt die Lösung nicht – der Archivfund ist auch Lab-Aufgabe W0-A-01, Korrektur D15).
+Lösung zum Vergleich: dieflot / telaeuf / tbeineu / mondaus → „die flotte laeuft bei neumond aus“.
+Begriffe am Fund benennen: Klartext, Geheimtext (DTTMI …), Schlüssel = Umfang des Stabes = 4 Zeilen.
 Historische Vorsicht: Die Skytale ist durch Plutarch (Lysander-Biografie, um 100 n. Chr.) und frühere Erwähnungen überliefert; ob sie tatsächlich der Geheimhaltung diente, ist in der Forschung umstritten – „gilt als“, „wird überliefert“.</a:t>
             </a:r>
             <a:endParaRPr lang="en-US" dirty="0"/>
@@ -4949,7 +4950,7 @@
                 <a:ea typeface="Consolas" pitchFamily="34" charset="-122"/>
                 <a:cs typeface="Consolas" pitchFamily="34" charset="-120"/>
               </a:rPr>
-              <a:t>wir halten den pass</a:t>
+              <a:t>wir kommen am abend</a:t>
             </a:r>
             <a:r>
               <a:rPr lang="en-US" sz="2200" dirty="0">
@@ -5024,7 +5025,7 @@
                 <a:ea typeface="Consolas" pitchFamily="34" charset="-122"/>
                 <a:cs typeface="Consolas" pitchFamily="34" charset="-120"/>
               </a:rPr>
-              <a:t>wirhal / tenden / pass</a:t>
+              <a:t>wirkom / menama / bend</a:t>
             </a:r>
             <a:endParaRPr lang="en-US" sz="1800" dirty="0"/>
           </a:p>
@@ -5242,7 +5243,7 @@
                 <a:ea typeface="Consolas" pitchFamily="34" charset="-122"/>
                 <a:cs typeface="Consolas" pitchFamily="34" charset="-120"/>
               </a:rPr>
-              <a:t>wirhal / tenden / passxx</a:t>
+              <a:t>wirkom / menama / bendxx</a:t>
             </a:r>
             <a:endParaRPr lang="en-US" sz="1800" dirty="0"/>
           </a:p>
@@ -5309,7 +5310,7 @@
                 <a:ea typeface="Consolas" pitchFamily="34" charset="-122"/>
                 <a:cs typeface="Consolas" pitchFamily="34" charset="-120"/>
               </a:rPr>
-              <a:t>WTPIE ARNSH DSAEX LNX</a:t>
+              <a:t>WMBIE ERNNK ADOMX MAX</a:t>
             </a:r>
             <a:endParaRPr lang="en-US" sz="1800" dirty="0"/>
           </a:p>
@@ -27306,7 +27307,7 @@
                 <a:ea typeface="Georgia" pitchFamily="34" charset="-122"/>
                 <a:cs typeface="Georgia" pitchFamily="34" charset="-120"/>
               </a:rPr>
-              <a:t>Die Lösung: 4 Zeilen, 7 Spalten</a:t>
+              <a:t>Der Weg: 4 Zeilen, 7 Spalten</a:t>
             </a:r>
             <a:endParaRPr lang="en-US" sz="3000" dirty="0"/>
           </a:p>
@@ -28082,25 +28083,7 @@
                     <a:bodyPr/>
                     <a:lstStyle/>
                     <a:p>
-                      <a:pPr algn="ctr" indent="0" marL="0">
-                        <a:buNone/>
-                      </a:pPr>
-                      <a:r>
-                        <a:rPr lang="en-US" sz="2400" dirty="0">
-                          <a:solidFill>
-                            <a:srgbClr val="1B1B1F"/>
-                          </a:solidFill>
-                          <a:latin typeface="Consolas" pitchFamily="34" charset="0"/>
-                          <a:ea typeface="Consolas" pitchFamily="34" charset="-122"/>
-                          <a:cs typeface="Consolas" pitchFamily="34" charset="-120"/>
-                        </a:rPr>
-                        <a:t>i</a:t>
-                      </a:r>
-                      <a:endParaRPr lang="en-US" sz="2400" dirty="0">
-                        <a:latin typeface="Calibri" charset="0"/>
-                        <a:ea typeface="Calibri" charset="0"/>
-                        <a:cs typeface="Calibri" charset="0"/>
-                      </a:endParaRPr>
+                      <a:endParaRPr/>
                     </a:p>
                   </a:txBody>
                   <a:tcPr marL="64008" marR="64008" marT="36576" marB="36576" anchor="ctr">
@@ -28150,25 +28133,7 @@
                     <a:bodyPr/>
                     <a:lstStyle/>
                     <a:p>
-                      <a:pPr algn="ctr" indent="0" marL="0">
-                        <a:buNone/>
-                      </a:pPr>
-                      <a:r>
-                        <a:rPr lang="en-US" sz="2400" dirty="0">
-                          <a:solidFill>
-                            <a:srgbClr val="1B1B1F"/>
-                          </a:solidFill>
-                          <a:latin typeface="Consolas" pitchFamily="34" charset="0"/>
-                          <a:ea typeface="Consolas" pitchFamily="34" charset="-122"/>
-                          <a:cs typeface="Consolas" pitchFamily="34" charset="-120"/>
-                        </a:rPr>
-                        <a:t>e</a:t>
-                      </a:r>
-                      <a:endParaRPr lang="en-US" sz="2400" dirty="0">
-                        <a:latin typeface="Calibri" charset="0"/>
-                        <a:ea typeface="Calibri" charset="0"/>
-                        <a:cs typeface="Calibri" charset="0"/>
-                      </a:endParaRPr>
+                      <a:endParaRPr/>
                     </a:p>
                   </a:txBody>
                   <a:tcPr marL="64008" marR="64008" marT="36576" marB="36576" anchor="ctr">
@@ -28218,25 +28183,7 @@
                     <a:bodyPr/>
                     <a:lstStyle/>
                     <a:p>
-                      <a:pPr algn="ctr" indent="0" marL="0">
-                        <a:buNone/>
-                      </a:pPr>
-                      <a:r>
-                        <a:rPr lang="en-US" sz="2400" dirty="0">
-                          <a:solidFill>
-                            <a:srgbClr val="1B1B1F"/>
-                          </a:solidFill>
-                          <a:latin typeface="Consolas" pitchFamily="34" charset="0"/>
-                          <a:ea typeface="Consolas" pitchFamily="34" charset="-122"/>
-                          <a:cs typeface="Consolas" pitchFamily="34" charset="-120"/>
-                        </a:rPr>
-                        <a:t>f</a:t>
-                      </a:r>
-                      <a:endParaRPr lang="en-US" sz="2400" dirty="0">
-                        <a:latin typeface="Calibri" charset="0"/>
-                        <a:ea typeface="Calibri" charset="0"/>
-                        <a:cs typeface="Calibri" charset="0"/>
-                      </a:endParaRPr>
+                      <a:endParaRPr/>
                     </a:p>
                   </a:txBody>
                   <a:tcPr marL="64008" marR="64008" marT="36576" marB="36576" anchor="ctr">
@@ -28286,25 +28233,7 @@
                     <a:bodyPr/>
                     <a:lstStyle/>
                     <a:p>
-                      <a:pPr algn="ctr" indent="0" marL="0">
-                        <a:buNone/>
-                      </a:pPr>
-                      <a:r>
-                        <a:rPr lang="en-US" sz="2400" dirty="0">
-                          <a:solidFill>
-                            <a:srgbClr val="1B1B1F"/>
-                          </a:solidFill>
-                          <a:latin typeface="Consolas" pitchFamily="34" charset="0"/>
-                          <a:ea typeface="Consolas" pitchFamily="34" charset="-122"/>
-                          <a:cs typeface="Consolas" pitchFamily="34" charset="-120"/>
-                        </a:rPr>
-                        <a:t>l</a:t>
-                      </a:r>
-                      <a:endParaRPr lang="en-US" sz="2400" dirty="0">
-                        <a:latin typeface="Calibri" charset="0"/>
-                        <a:ea typeface="Calibri" charset="0"/>
-                        <a:cs typeface="Calibri" charset="0"/>
-                      </a:endParaRPr>
+                      <a:endParaRPr/>
                     </a:p>
                   </a:txBody>
                   <a:tcPr marL="64008" marR="64008" marT="36576" marB="36576" anchor="ctr">
@@ -28354,25 +28283,7 @@
                     <a:bodyPr/>
                     <a:lstStyle/>
                     <a:p>
-                      <a:pPr algn="ctr" indent="0" marL="0">
-                        <a:buNone/>
-                      </a:pPr>
-                      <a:r>
-                        <a:rPr lang="en-US" sz="2400" dirty="0">
-                          <a:solidFill>
-                            <a:srgbClr val="1B1B1F"/>
-                          </a:solidFill>
-                          <a:latin typeface="Consolas" pitchFamily="34" charset="0"/>
-                          <a:ea typeface="Consolas" pitchFamily="34" charset="-122"/>
-                          <a:cs typeface="Consolas" pitchFamily="34" charset="-120"/>
-                        </a:rPr>
-                        <a:t>o</a:t>
-                      </a:r>
-                      <a:endParaRPr lang="en-US" sz="2400" dirty="0">
-                        <a:latin typeface="Calibri" charset="0"/>
-                        <a:ea typeface="Calibri" charset="0"/>
-                        <a:cs typeface="Calibri" charset="0"/>
-                      </a:endParaRPr>
+                      <a:endParaRPr/>
                     </a:p>
                   </a:txBody>
                   <a:tcPr marL="64008" marR="64008" marT="36576" marB="36576" anchor="ctr">
@@ -28422,25 +28333,7 @@
                     <a:bodyPr/>
                     <a:lstStyle/>
                     <a:p>
-                      <a:pPr algn="ctr" indent="0" marL="0">
-                        <a:buNone/>
-                      </a:pPr>
-                      <a:r>
-                        <a:rPr lang="en-US" sz="2400" dirty="0">
-                          <a:solidFill>
-                            <a:srgbClr val="1B1B1F"/>
-                          </a:solidFill>
-                          <a:latin typeface="Consolas" pitchFamily="34" charset="0"/>
-                          <a:ea typeface="Consolas" pitchFamily="34" charset="-122"/>
-                          <a:cs typeface="Consolas" pitchFamily="34" charset="-120"/>
-                        </a:rPr>
-                        <a:t>t</a:t>
-                      </a:r>
-                      <a:endParaRPr lang="en-US" sz="2400" dirty="0">
-                        <a:latin typeface="Calibri" charset="0"/>
-                        <a:ea typeface="Calibri" charset="0"/>
-                        <a:cs typeface="Calibri" charset="0"/>
-                      </a:endParaRPr>
+                      <a:endParaRPr/>
                     </a:p>
                   </a:txBody>
                   <a:tcPr marL="64008" marR="64008" marT="36576" marB="36576" anchor="ctr">
@@ -28628,25 +28521,7 @@
                     <a:bodyPr/>
                     <a:lstStyle/>
                     <a:p>
-                      <a:pPr algn="ctr" indent="0" marL="0">
-                        <a:buNone/>
-                      </a:pPr>
-                      <a:r>
-                        <a:rPr lang="en-US" sz="2400" dirty="0">
-                          <a:solidFill>
-                            <a:srgbClr val="1B1B1F"/>
-                          </a:solidFill>
-                          <a:latin typeface="Consolas" pitchFamily="34" charset="0"/>
-                          <a:ea typeface="Consolas" pitchFamily="34" charset="-122"/>
-                          <a:cs typeface="Consolas" pitchFamily="34" charset="-120"/>
-                        </a:rPr>
-                        <a:t>e</a:t>
-                      </a:r>
-                      <a:endParaRPr lang="en-US" sz="2400" dirty="0">
-                        <a:latin typeface="Calibri" charset="0"/>
-                        <a:ea typeface="Calibri" charset="0"/>
-                        <a:cs typeface="Calibri" charset="0"/>
-                      </a:endParaRPr>
+                      <a:endParaRPr/>
                     </a:p>
                   </a:txBody>
                   <a:tcPr marL="64008" marR="64008" marT="36576" marB="36576" anchor="ctr">
@@ -28696,25 +28571,7 @@
                     <a:bodyPr/>
                     <a:lstStyle/>
                     <a:p>
-                      <a:pPr algn="ctr" indent="0" marL="0">
-                        <a:buNone/>
-                      </a:pPr>
-                      <a:r>
-                        <a:rPr lang="en-US" sz="2400" dirty="0">
-                          <a:solidFill>
-                            <a:srgbClr val="1B1B1F"/>
-                          </a:solidFill>
-                          <a:latin typeface="Consolas" pitchFamily="34" charset="0"/>
-                          <a:ea typeface="Consolas" pitchFamily="34" charset="-122"/>
-                          <a:cs typeface="Consolas" pitchFamily="34" charset="-120"/>
-                        </a:rPr>
-                        <a:t>l</a:t>
-                      </a:r>
-                      <a:endParaRPr lang="en-US" sz="2400" dirty="0">
-                        <a:latin typeface="Calibri" charset="0"/>
-                        <a:ea typeface="Calibri" charset="0"/>
-                        <a:cs typeface="Calibri" charset="0"/>
-                      </a:endParaRPr>
+                      <a:endParaRPr/>
                     </a:p>
                   </a:txBody>
                   <a:tcPr marL="64008" marR="64008" marT="36576" marB="36576" anchor="ctr">
@@ -28764,25 +28621,7 @@
                     <a:bodyPr/>
                     <a:lstStyle/>
                     <a:p>
-                      <a:pPr algn="ctr" indent="0" marL="0">
-                        <a:buNone/>
-                      </a:pPr>
-                      <a:r>
-                        <a:rPr lang="en-US" sz="2400" dirty="0">
-                          <a:solidFill>
-                            <a:srgbClr val="1B1B1F"/>
-                          </a:solidFill>
-                          <a:latin typeface="Consolas" pitchFamily="34" charset="0"/>
-                          <a:ea typeface="Consolas" pitchFamily="34" charset="-122"/>
-                          <a:cs typeface="Consolas" pitchFamily="34" charset="-120"/>
-                        </a:rPr>
-                        <a:t>a</a:t>
-                      </a:r>
-                      <a:endParaRPr lang="en-US" sz="2400" dirty="0">
-                        <a:latin typeface="Calibri" charset="0"/>
-                        <a:ea typeface="Calibri" charset="0"/>
-                        <a:cs typeface="Calibri" charset="0"/>
-                      </a:endParaRPr>
+                      <a:endParaRPr/>
                     </a:p>
                   </a:txBody>
                   <a:tcPr marL="64008" marR="64008" marT="36576" marB="36576" anchor="ctr">
@@ -28832,25 +28671,7 @@
                     <a:bodyPr/>
                     <a:lstStyle/>
                     <a:p>
-                      <a:pPr algn="ctr" indent="0" marL="0">
-                        <a:buNone/>
-                      </a:pPr>
-                      <a:r>
-                        <a:rPr lang="en-US" sz="2400" dirty="0">
-                          <a:solidFill>
-                            <a:srgbClr val="1B1B1F"/>
-                          </a:solidFill>
-                          <a:latin typeface="Consolas" pitchFamily="34" charset="0"/>
-                          <a:ea typeface="Consolas" pitchFamily="34" charset="-122"/>
-                          <a:cs typeface="Consolas" pitchFamily="34" charset="-120"/>
-                        </a:rPr>
-                        <a:t>e</a:t>
-                      </a:r>
-                      <a:endParaRPr lang="en-US" sz="2400" dirty="0">
-                        <a:latin typeface="Calibri" charset="0"/>
-                        <a:ea typeface="Calibri" charset="0"/>
-                        <a:cs typeface="Calibri" charset="0"/>
-                      </a:endParaRPr>
+                      <a:endParaRPr/>
                     </a:p>
                   </a:txBody>
                   <a:tcPr marL="64008" marR="64008" marT="36576" marB="36576" anchor="ctr">
@@ -28900,25 +28721,7 @@
                     <a:bodyPr/>
                     <a:lstStyle/>
                     <a:p>
-                      <a:pPr algn="ctr" indent="0" marL="0">
-                        <a:buNone/>
-                      </a:pPr>
-                      <a:r>
-                        <a:rPr lang="en-US" sz="2400" dirty="0">
-                          <a:solidFill>
-                            <a:srgbClr val="1B1B1F"/>
-                          </a:solidFill>
-                          <a:latin typeface="Consolas" pitchFamily="34" charset="0"/>
-                          <a:ea typeface="Consolas" pitchFamily="34" charset="-122"/>
-                          <a:cs typeface="Consolas" pitchFamily="34" charset="-120"/>
-                        </a:rPr>
-                        <a:t>u</a:t>
-                      </a:r>
-                      <a:endParaRPr lang="en-US" sz="2400" dirty="0">
-                        <a:latin typeface="Calibri" charset="0"/>
-                        <a:ea typeface="Calibri" charset="0"/>
-                        <a:cs typeface="Calibri" charset="0"/>
-                      </a:endParaRPr>
+                      <a:endParaRPr/>
                     </a:p>
                   </a:txBody>
                   <a:tcPr marL="64008" marR="64008" marT="36576" marB="36576" anchor="ctr">
@@ -28968,25 +28771,7 @@
                     <a:bodyPr/>
                     <a:lstStyle/>
                     <a:p>
-                      <a:pPr algn="ctr" indent="0" marL="0">
-                        <a:buNone/>
-                      </a:pPr>
-                      <a:r>
-                        <a:rPr lang="en-US" sz="2400" dirty="0">
-                          <a:solidFill>
-                            <a:srgbClr val="1B1B1F"/>
-                          </a:solidFill>
-                          <a:latin typeface="Consolas" pitchFamily="34" charset="0"/>
-                          <a:ea typeface="Consolas" pitchFamily="34" charset="-122"/>
-                          <a:cs typeface="Consolas" pitchFamily="34" charset="-120"/>
-                        </a:rPr>
-                        <a:t>f</a:t>
-                      </a:r>
-                      <a:endParaRPr lang="en-US" sz="2400" dirty="0">
-                        <a:latin typeface="Calibri" charset="0"/>
-                        <a:ea typeface="Calibri" charset="0"/>
-                        <a:cs typeface="Calibri" charset="0"/>
-                      </a:endParaRPr>
+                      <a:endParaRPr/>
                     </a:p>
                   </a:txBody>
                   <a:tcPr marL="64008" marR="64008" marT="36576" marB="36576" anchor="ctr">
@@ -29174,25 +28959,7 @@
                     <a:bodyPr/>
                     <a:lstStyle/>
                     <a:p>
-                      <a:pPr algn="ctr" indent="0" marL="0">
-                        <a:buNone/>
-                      </a:pPr>
-                      <a:r>
-                        <a:rPr lang="en-US" sz="2400" dirty="0">
-                          <a:solidFill>
-                            <a:srgbClr val="1B1B1F"/>
-                          </a:solidFill>
-                          <a:latin typeface="Consolas" pitchFamily="34" charset="0"/>
-                          <a:ea typeface="Consolas" pitchFamily="34" charset="-122"/>
-                          <a:cs typeface="Consolas" pitchFamily="34" charset="-120"/>
-                        </a:rPr>
-                        <a:t>b</a:t>
-                      </a:r>
-                      <a:endParaRPr lang="en-US" sz="2400" dirty="0">
-                        <a:latin typeface="Calibri" charset="0"/>
-                        <a:ea typeface="Calibri" charset="0"/>
-                        <a:cs typeface="Calibri" charset="0"/>
-                      </a:endParaRPr>
+                      <a:endParaRPr/>
                     </a:p>
                   </a:txBody>
                   <a:tcPr marL="64008" marR="64008" marT="36576" marB="36576" anchor="ctr">
@@ -29242,25 +29009,7 @@
                     <a:bodyPr/>
                     <a:lstStyle/>
                     <a:p>
-                      <a:pPr algn="ctr" indent="0" marL="0">
-                        <a:buNone/>
-                      </a:pPr>
-                      <a:r>
-                        <a:rPr lang="en-US" sz="2400" dirty="0">
-                          <a:solidFill>
-                            <a:srgbClr val="1B1B1F"/>
-                          </a:solidFill>
-                          <a:latin typeface="Consolas" pitchFamily="34" charset="0"/>
-                          <a:ea typeface="Consolas" pitchFamily="34" charset="-122"/>
-                          <a:cs typeface="Consolas" pitchFamily="34" charset="-120"/>
-                        </a:rPr>
-                        <a:t>e</a:t>
-                      </a:r>
-                      <a:endParaRPr lang="en-US" sz="2400" dirty="0">
-                        <a:latin typeface="Calibri" charset="0"/>
-                        <a:ea typeface="Calibri" charset="0"/>
-                        <a:cs typeface="Calibri" charset="0"/>
-                      </a:endParaRPr>
+                      <a:endParaRPr/>
                     </a:p>
                   </a:txBody>
                   <a:tcPr marL="64008" marR="64008" marT="36576" marB="36576" anchor="ctr">
@@ -29310,25 +29059,7 @@
                     <a:bodyPr/>
                     <a:lstStyle/>
                     <a:p>
-                      <a:pPr algn="ctr" indent="0" marL="0">
-                        <a:buNone/>
-                      </a:pPr>
-                      <a:r>
-                        <a:rPr lang="en-US" sz="2400" dirty="0">
-                          <a:solidFill>
-                            <a:srgbClr val="1B1B1F"/>
-                          </a:solidFill>
-                          <a:latin typeface="Consolas" pitchFamily="34" charset="0"/>
-                          <a:ea typeface="Consolas" pitchFamily="34" charset="-122"/>
-                          <a:cs typeface="Consolas" pitchFamily="34" charset="-120"/>
-                        </a:rPr>
-                        <a:t>i</a:t>
-                      </a:r>
-                      <a:endParaRPr lang="en-US" sz="2400" dirty="0">
-                        <a:latin typeface="Calibri" charset="0"/>
-                        <a:ea typeface="Calibri" charset="0"/>
-                        <a:cs typeface="Calibri" charset="0"/>
-                      </a:endParaRPr>
+                      <a:endParaRPr/>
                     </a:p>
                   </a:txBody>
                   <a:tcPr marL="64008" marR="64008" marT="36576" marB="36576" anchor="ctr">
@@ -29378,25 +29109,7 @@
                     <a:bodyPr/>
                     <a:lstStyle/>
                     <a:p>
-                      <a:pPr algn="ctr" indent="0" marL="0">
-                        <a:buNone/>
-                      </a:pPr>
-                      <a:r>
-                        <a:rPr lang="en-US" sz="2400" dirty="0">
-                          <a:solidFill>
-                            <a:srgbClr val="1B1B1F"/>
-                          </a:solidFill>
-                          <a:latin typeface="Consolas" pitchFamily="34" charset="0"/>
-                          <a:ea typeface="Consolas" pitchFamily="34" charset="-122"/>
-                          <a:cs typeface="Consolas" pitchFamily="34" charset="-120"/>
-                        </a:rPr>
-                        <a:t>n</a:t>
-                      </a:r>
-                      <a:endParaRPr lang="en-US" sz="2400" dirty="0">
-                        <a:latin typeface="Calibri" charset="0"/>
-                        <a:ea typeface="Calibri" charset="0"/>
-                        <a:cs typeface="Calibri" charset="0"/>
-                      </a:endParaRPr>
+                      <a:endParaRPr/>
                     </a:p>
                   </a:txBody>
                   <a:tcPr marL="64008" marR="64008" marT="36576" marB="36576" anchor="ctr">
@@ -29446,25 +29159,7 @@
                     <a:bodyPr/>
                     <a:lstStyle/>
                     <a:p>
-                      <a:pPr algn="ctr" indent="0" marL="0">
-                        <a:buNone/>
-                      </a:pPr>
-                      <a:r>
-                        <a:rPr lang="en-US" sz="2400" dirty="0">
-                          <a:solidFill>
-                            <a:srgbClr val="1B1B1F"/>
-                          </a:solidFill>
-                          <a:latin typeface="Consolas" pitchFamily="34" charset="0"/>
-                          <a:ea typeface="Consolas" pitchFamily="34" charset="-122"/>
-                          <a:cs typeface="Consolas" pitchFamily="34" charset="-120"/>
-                        </a:rPr>
-                        <a:t>e</a:t>
-                      </a:r>
-                      <a:endParaRPr lang="en-US" sz="2400" dirty="0">
-                        <a:latin typeface="Calibri" charset="0"/>
-                        <a:ea typeface="Calibri" charset="0"/>
-                        <a:cs typeface="Calibri" charset="0"/>
-                      </a:endParaRPr>
+                      <a:endParaRPr/>
                     </a:p>
                   </a:txBody>
                   <a:tcPr marL="64008" marR="64008" marT="36576" marB="36576" anchor="ctr">
@@ -29514,25 +29209,7 @@
                     <a:bodyPr/>
                     <a:lstStyle/>
                     <a:p>
-                      <a:pPr algn="ctr" indent="0" marL="0">
-                        <a:buNone/>
-                      </a:pPr>
-                      <a:r>
-                        <a:rPr lang="en-US" sz="2400" dirty="0">
-                          <a:solidFill>
-                            <a:srgbClr val="1B1B1F"/>
-                          </a:solidFill>
-                          <a:latin typeface="Consolas" pitchFamily="34" charset="0"/>
-                          <a:ea typeface="Consolas" pitchFamily="34" charset="-122"/>
-                          <a:cs typeface="Consolas" pitchFamily="34" charset="-120"/>
-                        </a:rPr>
-                        <a:t>u</a:t>
-                      </a:r>
-                      <a:endParaRPr lang="en-US" sz="2400" dirty="0">
-                        <a:latin typeface="Calibri" charset="0"/>
-                        <a:ea typeface="Calibri" charset="0"/>
-                        <a:cs typeface="Calibri" charset="0"/>
-                      </a:endParaRPr>
+                      <a:endParaRPr/>
                     </a:p>
                   </a:txBody>
                   <a:tcPr marL="64008" marR="64008" marT="36576" marB="36576" anchor="ctr">
@@ -29720,25 +29397,7 @@
                     <a:bodyPr/>
                     <a:lstStyle/>
                     <a:p>
-                      <a:pPr algn="ctr" indent="0" marL="0">
-                        <a:buNone/>
-                      </a:pPr>
-                      <a:r>
-                        <a:rPr lang="en-US" sz="2400" dirty="0">
-                          <a:solidFill>
-                            <a:srgbClr val="1B1B1F"/>
-                          </a:solidFill>
-                          <a:latin typeface="Consolas" pitchFamily="34" charset="0"/>
-                          <a:ea typeface="Consolas" pitchFamily="34" charset="-122"/>
-                          <a:cs typeface="Consolas" pitchFamily="34" charset="-120"/>
-                        </a:rPr>
-                        <a:t>o</a:t>
-                      </a:r>
-                      <a:endParaRPr lang="en-US" sz="2400" dirty="0">
-                        <a:latin typeface="Calibri" charset="0"/>
-                        <a:ea typeface="Calibri" charset="0"/>
-                        <a:cs typeface="Calibri" charset="0"/>
-                      </a:endParaRPr>
+                      <a:endParaRPr/>
                     </a:p>
                   </a:txBody>
                   <a:tcPr marL="64008" marR="64008" marT="36576" marB="36576" anchor="ctr">
@@ -29788,25 +29447,7 @@
                     <a:bodyPr/>
                     <a:lstStyle/>
                     <a:p>
-                      <a:pPr algn="ctr" indent="0" marL="0">
-                        <a:buNone/>
-                      </a:pPr>
-                      <a:r>
-                        <a:rPr lang="en-US" sz="2400" dirty="0">
-                          <a:solidFill>
-                            <a:srgbClr val="1B1B1F"/>
-                          </a:solidFill>
-                          <a:latin typeface="Consolas" pitchFamily="34" charset="0"/>
-                          <a:ea typeface="Consolas" pitchFamily="34" charset="-122"/>
-                          <a:cs typeface="Consolas" pitchFamily="34" charset="-120"/>
-                        </a:rPr>
-                        <a:t>n</a:t>
-                      </a:r>
-                      <a:endParaRPr lang="en-US" sz="2400" dirty="0">
-                        <a:latin typeface="Calibri" charset="0"/>
-                        <a:ea typeface="Calibri" charset="0"/>
-                        <a:cs typeface="Calibri" charset="0"/>
-                      </a:endParaRPr>
+                      <a:endParaRPr/>
                     </a:p>
                   </a:txBody>
                   <a:tcPr marL="64008" marR="64008" marT="36576" marB="36576" anchor="ctr">
@@ -29856,25 +29497,7 @@
                     <a:bodyPr/>
                     <a:lstStyle/>
                     <a:p>
-                      <a:pPr algn="ctr" indent="0" marL="0">
-                        <a:buNone/>
-                      </a:pPr>
-                      <a:r>
-                        <a:rPr lang="en-US" sz="2400" dirty="0">
-                          <a:solidFill>
-                            <a:srgbClr val="1B1B1F"/>
-                          </a:solidFill>
-                          <a:latin typeface="Consolas" pitchFamily="34" charset="0"/>
-                          <a:ea typeface="Consolas" pitchFamily="34" charset="-122"/>
-                          <a:cs typeface="Consolas" pitchFamily="34" charset="-120"/>
-                        </a:rPr>
-                        <a:t>d</a:t>
-                      </a:r>
-                      <a:endParaRPr lang="en-US" sz="2400" dirty="0">
-                        <a:latin typeface="Calibri" charset="0"/>
-                        <a:ea typeface="Calibri" charset="0"/>
-                        <a:cs typeface="Calibri" charset="0"/>
-                      </a:endParaRPr>
+                      <a:endParaRPr/>
                     </a:p>
                   </a:txBody>
                   <a:tcPr marL="64008" marR="64008" marT="36576" marB="36576" anchor="ctr">
@@ -29924,25 +29547,7 @@
                     <a:bodyPr/>
                     <a:lstStyle/>
                     <a:p>
-                      <a:pPr algn="ctr" indent="0" marL="0">
-                        <a:buNone/>
-                      </a:pPr>
-                      <a:r>
-                        <a:rPr lang="en-US" sz="2400" dirty="0">
-                          <a:solidFill>
-                            <a:srgbClr val="1B1B1F"/>
-                          </a:solidFill>
-                          <a:latin typeface="Consolas" pitchFamily="34" charset="0"/>
-                          <a:ea typeface="Consolas" pitchFamily="34" charset="-122"/>
-                          <a:cs typeface="Consolas" pitchFamily="34" charset="-120"/>
-                        </a:rPr>
-                        <a:t>a</a:t>
-                      </a:r>
-                      <a:endParaRPr lang="en-US" sz="2400" dirty="0">
-                        <a:latin typeface="Calibri" charset="0"/>
-                        <a:ea typeface="Calibri" charset="0"/>
-                        <a:cs typeface="Calibri" charset="0"/>
-                      </a:endParaRPr>
+                      <a:endParaRPr/>
                     </a:p>
                   </a:txBody>
                   <a:tcPr marL="64008" marR="64008" marT="36576" marB="36576" anchor="ctr">
@@ -29992,25 +29597,7 @@
                     <a:bodyPr/>
                     <a:lstStyle/>
                     <a:p>
-                      <a:pPr algn="ctr" indent="0" marL="0">
-                        <a:buNone/>
-                      </a:pPr>
-                      <a:r>
-                        <a:rPr lang="en-US" sz="2400" dirty="0">
-                          <a:solidFill>
-                            <a:srgbClr val="1B1B1F"/>
-                          </a:solidFill>
-                          <a:latin typeface="Consolas" pitchFamily="34" charset="0"/>
-                          <a:ea typeface="Consolas" pitchFamily="34" charset="-122"/>
-                          <a:cs typeface="Consolas" pitchFamily="34" charset="-120"/>
-                        </a:rPr>
-                        <a:t>u</a:t>
-                      </a:r>
-                      <a:endParaRPr lang="en-US" sz="2400" dirty="0">
-                        <a:latin typeface="Calibri" charset="0"/>
-                        <a:ea typeface="Calibri" charset="0"/>
-                        <a:cs typeface="Calibri" charset="0"/>
-                      </a:endParaRPr>
+                      <a:endParaRPr/>
                     </a:p>
                   </a:txBody>
                   <a:tcPr marL="64008" marR="64008" marT="36576" marB="36576" anchor="ctr">
@@ -30060,25 +29647,7 @@
                     <a:bodyPr/>
                     <a:lstStyle/>
                     <a:p>
-                      <a:pPr algn="ctr" indent="0" marL="0">
-                        <a:buNone/>
-                      </a:pPr>
-                      <a:r>
-                        <a:rPr lang="en-US" sz="2400" dirty="0">
-                          <a:solidFill>
-                            <a:srgbClr val="1B1B1F"/>
-                          </a:solidFill>
-                          <a:latin typeface="Consolas" pitchFamily="34" charset="0"/>
-                          <a:ea typeface="Consolas" pitchFamily="34" charset="-122"/>
-                          <a:cs typeface="Consolas" pitchFamily="34" charset="-120"/>
-                        </a:rPr>
-                        <a:t>s</a:t>
-                      </a:r>
-                      <a:endParaRPr lang="en-US" sz="2400" dirty="0">
-                        <a:latin typeface="Calibri" charset="0"/>
-                        <a:ea typeface="Calibri" charset="0"/>
-                        <a:cs typeface="Calibri" charset="0"/>
-                      </a:endParaRPr>
+                      <a:endParaRPr/>
                     </a:p>
                   </a:txBody>
                   <a:tcPr marL="64008" marR="64008" marT="36576" marB="36576" anchor="ctr">
@@ -30158,7 +29727,7 @@
                   <a:srgbClr val="1B1B1F"/>
                 </a:solidFill>
               </a:rPr>
-              <a:t>Klartext: </a:t>
+              <a:t>Klartext: Zeile für Zeile lesen – </a:t>
             </a:r>
             <a:r>
               <a:rPr lang="en-US" sz="2200" b="1" dirty="0">
@@ -30166,7 +29735,7 @@
                   <a:srgbClr val="B5523B"/>
                 </a:solidFill>
               </a:rPr>
-              <a:t>die flotte laeuft bei neumond aus</a:t>
+              <a:t>gemeinsam an der Tafel</a:t>
             </a:r>
             <a:endParaRPr lang="en-US" sz="2200" dirty="0"/>
           </a:p>

</xml_diff>